<commit_message>
Complete ideathon readiness with real Sentinel-5P evidence
</commit_message>
<xml_diff>
--- a/downloads/AeroChem_Sentinel_Ideathon_Pitch_2026.pptx
+++ b/downloads/AeroChem_Sentinel_Ideathon_Pitch_2026.pptx
@@ -2,18 +2,18 @@
 <file path=ppt/presentation.xml><?xml version="1.0" encoding="utf-8"?>
 <p:presentation xmlns:p="http://schemas.openxmlformats.org/presentationml/2006/main">
   <p:sldMasterIdLst>
-    <p:sldMasterId xmlns:r="http://schemas.openxmlformats.org/officeDocument/2006/relationships" id="2147483648" r:id="R6127f4b5c4fb4070"/>
+    <p:sldMasterId xmlns:r="http://schemas.openxmlformats.org/officeDocument/2006/relationships" id="2147483648" r:id="R406245d787b4441c"/>
   </p:sldMasterIdLst>
   <p:notesMasterIdLst>
-    <p:notesMasterId xmlns:r="http://schemas.openxmlformats.org/officeDocument/2006/relationships" r:id="R2e1e3da1dfab4806"/>
+    <p:notesMasterId xmlns:r="http://schemas.openxmlformats.org/officeDocument/2006/relationships" r:id="Rcaf466ac34af4954"/>
   </p:notesMasterIdLst>
   <p:sldIdLst>
-    <p:sldId xmlns:r="http://schemas.openxmlformats.org/officeDocument/2006/relationships" id="256" r:id="R55701bb3a3a44c19"/>
-    <p:sldId xmlns:r="http://schemas.openxmlformats.org/officeDocument/2006/relationships" id="257" r:id="Rd444e6736fdf4ff1"/>
-    <p:sldId xmlns:r="http://schemas.openxmlformats.org/officeDocument/2006/relationships" id="258" r:id="Rabea99d489924b49"/>
-    <p:sldId xmlns:r="http://schemas.openxmlformats.org/officeDocument/2006/relationships" id="259" r:id="R93637532ff214778"/>
-    <p:sldId xmlns:r="http://schemas.openxmlformats.org/officeDocument/2006/relationships" id="260" r:id="R7daa1c1571714620"/>
-    <p:sldId xmlns:r="http://schemas.openxmlformats.org/officeDocument/2006/relationships" id="261" r:id="Ra92f4116196f4801"/>
+    <p:sldId xmlns:r="http://schemas.openxmlformats.org/officeDocument/2006/relationships" id="256" r:id="R49e6198bae2d40df"/>
+    <p:sldId xmlns:r="http://schemas.openxmlformats.org/officeDocument/2006/relationships" id="257" r:id="R1bdbfeedde844b37"/>
+    <p:sldId xmlns:r="http://schemas.openxmlformats.org/officeDocument/2006/relationships" id="258" r:id="Rabff2f0ffe554c61"/>
+    <p:sldId xmlns:r="http://schemas.openxmlformats.org/officeDocument/2006/relationships" id="259" r:id="Rca0873462b464b00"/>
+    <p:sldId xmlns:r="http://schemas.openxmlformats.org/officeDocument/2006/relationships" id="260" r:id="Rf045d99060e3463f"/>
+    <p:sldId xmlns:r="http://schemas.openxmlformats.org/officeDocument/2006/relationships" id="261" r:id="Rba7bcfda5e994866"/>
   </p:sldIdLst>
   <p:sldSz cx="12192000" cy="6858000"/>
   <p:notesSz cx="6858000" cy="9144000"/>
@@ -467,7 +467,7 @@
           </a:p>
           <a:p xmlns:a="http://schemas.openxmlformats.org/drawingml/2006/main">
             <a:r>
-              <a:t>- Dashboard screenshot captured 08 Aug 2026 from the working prototype.</a:t>
+              <a:t>- Dashboard screenshot refreshed 09 Aug 2026 from the working prototype.</a:t>
             </a:r>
           </a:p>
           <a:p xmlns:a="http://schemas.openxmlformats.org/drawingml/2006/main">
@@ -637,7 +637,7 @@
           <a:lstStyle xmlns:a="http://schemas.openxmlformats.org/drawingml/2006/main"/>
           <a:p xmlns:a="http://schemas.openxmlformats.org/drawingml/2006/main">
             <a:r>
-              <a:t>Sumit demonstrates the live site. Emphasize the labels: the HCHO and NO2 values are CAMS near-surface model context. The separate Sentinel-5P column raster is still a future integration and is never conflated with these values.</a:t>
+              <a:t>Sumit enables the Sentinel-5P layer in the live site. Emphasize the labels: NASA GIBS supplies the dated atmospheric NO2 column, while the numeric HCHO, NO2 and AQI values remain CAMS near-surface model context. Neither is presented as a ground-sensor reading.</a:t>
             </a:r>
           </a:p>
           <a:p xmlns:a="http://schemas.openxmlformats.org/drawingml/2006/main">
@@ -657,12 +657,12 @@
           </a:p>
           <a:p xmlns:a="http://schemas.openxmlformats.org/drawingml/2006/main">
             <a:r>
-              <a:t>- https://sentinels.copernicus.eu/documents/247904/2474726/Sentinel-5P-Level-2-Product-User-Manual-Formaldehyde</a:t>
-            </a:r>
-          </a:p>
-          <a:p xmlns:a="http://schemas.openxmlformats.org/drawingml/2006/main">
-            <a:r>
-              <a:t>- Dashboard snapshot generated 08 Aug 2026 at Malegaon coordinates.</a:t>
+              <a:t>- https://gibs.earthdata.nasa.gov/layer-metadata/v1.0/TROPOMI_L2_Nitrogen_Dioxide_Tropospheric_Column.json</a:t>
+            </a:r>
+          </a:p>
+          <a:p xmlns:a="http://schemas.openxmlformats.org/drawingml/2006/main">
+            <a:r>
+              <a:t>- Dashboard snapshot refreshed 09 Aug 2026 at Malegaon coordinates.</a:t>
             </a:r>
           </a:p>
           <a:p xmlns:a="http://schemas.openxmlformats.org/drawingml/2006/main">
@@ -1025,7 +1025,7 @@
   </p:cSld>
   <p:clrMap bg1="lt1" tx1="dk1" bg2="lt2" tx2="dk2" accent1="accent1" accent2="accent2" accent3="accent3" accent4="accent4" accent5="accent5" accent6="accent6" hlink="hlink" folHlink="folHlink"/>
   <p:sldLayoutIdLst>
-    <p:sldLayoutId xmlns:r="http://schemas.openxmlformats.org/officeDocument/2006/relationships" id="2147483649" r:id="R4da6fd7377154d0b"/>
+    <p:sldLayoutId xmlns:r="http://schemas.openxmlformats.org/officeDocument/2006/relationships" id="2147483649" r:id="Rb6f75e0e351a42be"/>
   </p:sldLayoutIdLst>
   <p:txStyles>
     <p:titleStyle>
@@ -1580,7 +1580,7 @@
           <p:nvPr/>
         </p:nvPicPr>
         <p:blipFill>
-          <a:blip xmlns:r="http://schemas.openxmlformats.org/officeDocument/2006/relationships" xmlns:a="http://schemas.openxmlformats.org/drawingml/2006/main" r:embed="Rcd03cc0ec5e84841"/>
+          <a:blip xmlns:r="http://schemas.openxmlformats.org/officeDocument/2006/relationships" xmlns:a="http://schemas.openxmlformats.org/drawingml/2006/main" r:embed="Rb096be0dfe1049ad"/>
           <a:srcRect xmlns:a="http://schemas.openxmlformats.org/drawingml/2006/main" l="25000" t="0" r="25000" b="0"/>
           <a:stretch xmlns:a="http://schemas.openxmlformats.org/drawingml/2006/main">
             <a:fillRect l="0" t="0" r="0" b="0"/>
@@ -1601,7 +1601,7 @@
           <p:cNvPr id="2" name="title-left-field">
             <a:extLst xmlns:a="http://schemas.openxmlformats.org/drawingml/2006/main">
               <a:ext uri="{FF2B5EF4-FFF2-40B4-BE49-F238E27FC236}">
-                <a16:creationId xmlns:a16="http://schemas.microsoft.com/office/drawing/2014/main" id="{1A837F2A-6231-4F94-8C36-266F499BF57C}"/>
+                <a16:creationId xmlns:a16="http://schemas.microsoft.com/office/drawing/2014/main" id="{39B9CAE2-5FEE-4D42-B357-64B3626565A3}"/>
               </a:ext>
             </a:extLst>
           </p:cNvPr>
@@ -1632,7 +1632,7 @@
           <p:cNvPr id="3" name="title-accent">
             <a:extLst xmlns:a="http://schemas.openxmlformats.org/drawingml/2006/main">
               <a:ext uri="{FF2B5EF4-FFF2-40B4-BE49-F238E27FC236}">
-                <a16:creationId xmlns:a16="http://schemas.microsoft.com/office/drawing/2014/main" id="{807441EE-B1B9-4729-8A5D-E6FF4D8CB244}"/>
+                <a16:creationId xmlns:a16="http://schemas.microsoft.com/office/drawing/2014/main" id="{B3BA1195-5F2F-43A3-A458-74B3E4001D47}"/>
               </a:ext>
             </a:extLst>
           </p:cNvPr>
@@ -1663,7 +1663,7 @@
           <p:cNvPr id="4" name="title-kicker">
             <a:extLst xmlns:a="http://schemas.openxmlformats.org/drawingml/2006/main">
               <a:ext uri="{FF2B5EF4-FFF2-40B4-BE49-F238E27FC236}">
-                <a16:creationId xmlns:a16="http://schemas.microsoft.com/office/drawing/2014/main" id="{BAC61563-8B4C-4A61-A30B-FA0C080B215E}"/>
+                <a16:creationId xmlns:a16="http://schemas.microsoft.com/office/drawing/2014/main" id="{C2FDB8A9-E0BE-4C39-8C4C-0C929841EE80}"/>
               </a:ext>
             </a:extLst>
           </p:cNvPr>
@@ -1713,7 +1713,7 @@
           <p:cNvPr id="5" name="title-main">
             <a:extLst xmlns:a="http://schemas.openxmlformats.org/drawingml/2006/main">
               <a:ext uri="{FF2B5EF4-FFF2-40B4-BE49-F238E27FC236}">
-                <a16:creationId xmlns:a16="http://schemas.microsoft.com/office/drawing/2014/main" id="{F073DA62-56CE-4C00-9D8D-8FE07C292213}"/>
+                <a16:creationId xmlns:a16="http://schemas.microsoft.com/office/drawing/2014/main" id="{A108B705-75EB-4F3A-B4D7-306396A337EE}"/>
               </a:ext>
             </a:extLst>
           </p:cNvPr>
@@ -1780,7 +1780,7 @@
           <p:cNvPr id="6" name="title-subtitle">
             <a:extLst xmlns:a="http://schemas.openxmlformats.org/drawingml/2006/main">
               <a:ext uri="{FF2B5EF4-FFF2-40B4-BE49-F238E27FC236}">
-                <a16:creationId xmlns:a16="http://schemas.microsoft.com/office/drawing/2014/main" id="{63EC25A5-625A-48EA-AC0D-6CBF517120F0}"/>
+                <a16:creationId xmlns:a16="http://schemas.microsoft.com/office/drawing/2014/main" id="{1079A063-9173-4E76-8038-041540AB22AC}"/>
               </a:ext>
             </a:extLst>
           </p:cNvPr>
@@ -1830,7 +1830,7 @@
           <p:cNvPr id="7" name="title-location">
             <a:extLst xmlns:a="http://schemas.openxmlformats.org/drawingml/2006/main">
               <a:ext uri="{FF2B5EF4-FFF2-40B4-BE49-F238E27FC236}">
-                <a16:creationId xmlns:a16="http://schemas.microsoft.com/office/drawing/2014/main" id="{E4EA4273-2224-4BBA-AA9A-28CF5FBB2612}"/>
+                <a16:creationId xmlns:a16="http://schemas.microsoft.com/office/drawing/2014/main" id="{8F555D30-5E4F-4B07-97B5-21E51F9F14CE}"/>
               </a:ext>
             </a:extLst>
           </p:cNvPr>
@@ -1880,7 +1880,7 @@
           <p:cNvPr id="8" name="title-link">
             <a:extLst xmlns:a="http://schemas.openxmlformats.org/drawingml/2006/main">
               <a:ext uri="{FF2B5EF4-FFF2-40B4-BE49-F238E27FC236}">
-                <a16:creationId xmlns:a16="http://schemas.microsoft.com/office/drawing/2014/main" id="{E28F14B5-B115-4E3D-BAB4-31D01B8F2EC3}"/>
+                <a16:creationId xmlns:a16="http://schemas.microsoft.com/office/drawing/2014/main" id="{9A95A94F-89F8-4688-93C3-16A7E132ED78}"/>
               </a:ext>
             </a:extLst>
           </p:cNvPr>
@@ -1930,7 +1930,7 @@
           <p:cNvPr id="9" name="footer-brand-1">
             <a:extLst xmlns:a="http://schemas.openxmlformats.org/drawingml/2006/main">
               <a:ext uri="{FF2B5EF4-FFF2-40B4-BE49-F238E27FC236}">
-                <a16:creationId xmlns:a16="http://schemas.microsoft.com/office/drawing/2014/main" id="{BB670CC5-B522-42F6-937F-6B285888C7DC}"/>
+                <a16:creationId xmlns:a16="http://schemas.microsoft.com/office/drawing/2014/main" id="{11B32B41-E48C-4356-AD59-81FE419B490D}"/>
               </a:ext>
             </a:extLst>
           </p:cNvPr>
@@ -1980,7 +1980,7 @@
           <p:cNvPr id="10" name="footer-index-1">
             <a:extLst xmlns:a="http://schemas.openxmlformats.org/drawingml/2006/main">
               <a:ext uri="{FF2B5EF4-FFF2-40B4-BE49-F238E27FC236}">
-                <a16:creationId xmlns:a16="http://schemas.microsoft.com/office/drawing/2014/main" id="{393D82F0-4AF0-4602-9808-98EE97A1843E}"/>
+                <a16:creationId xmlns:a16="http://schemas.microsoft.com/office/drawing/2014/main" id="{21112179-B88F-4C5B-9C78-C8177AC6CDC4}"/>
               </a:ext>
             </a:extLst>
           </p:cNvPr>
@@ -2028,7 +2028,7 @@
     </p:spTree>
     <p:extLst>
       <p:ext uri="{BB962C8B-B14F-4D97-AF65-F5344CB8AC3E}">
-        <p14:creationId xmlns:p14="http://schemas.microsoft.com/office/powerpoint/2010/main" val="401335543"/>
+        <p14:creationId xmlns:p14="http://schemas.microsoft.com/office/powerpoint/2010/main" val="1588485691"/>
       </p:ext>
     </p:extLst>
   </p:cSld>
@@ -2059,7 +2059,7 @@
           <p:cNvPr id="14" name="problem-kicker">
             <a:extLst xmlns:a="http://schemas.openxmlformats.org/drawingml/2006/main">
               <a:ext uri="{FF2B5EF4-FFF2-40B4-BE49-F238E27FC236}">
-                <a16:creationId xmlns:a16="http://schemas.microsoft.com/office/drawing/2014/main" id="{3BCDD499-8923-4803-86A0-F15B98DD673F}"/>
+                <a16:creationId xmlns:a16="http://schemas.microsoft.com/office/drawing/2014/main" id="{9382AE9F-537D-4559-892F-0DFCAC13E970}"/>
               </a:ext>
             </a:extLst>
           </p:cNvPr>
@@ -2109,7 +2109,7 @@
           <p:cNvPr id="2" name="problem-title">
             <a:extLst xmlns:a="http://schemas.openxmlformats.org/drawingml/2006/main">
               <a:ext uri="{FF2B5EF4-FFF2-40B4-BE49-F238E27FC236}">
-                <a16:creationId xmlns:a16="http://schemas.microsoft.com/office/drawing/2014/main" id="{5EDD81F6-E3F6-4530-B21F-483E8771856B}"/>
+                <a16:creationId xmlns:a16="http://schemas.microsoft.com/office/drawing/2014/main" id="{F344A1FB-B3A8-4F3C-8B7A-B2BB487B3985}"/>
               </a:ext>
             </a:extLst>
           </p:cNvPr>
@@ -2159,7 +2159,7 @@
           <p:cNvPr id="3" name="problem-rule">
             <a:extLst xmlns:a="http://schemas.openxmlformats.org/drawingml/2006/main">
               <a:ext uri="{FF2B5EF4-FFF2-40B4-BE49-F238E27FC236}">
-                <a16:creationId xmlns:a16="http://schemas.microsoft.com/office/drawing/2014/main" id="{9CF24487-63DE-481E-BC3D-DC39BA6A5BF0}"/>
+                <a16:creationId xmlns:a16="http://schemas.microsoft.com/office/drawing/2014/main" id="{AB776765-5038-4B2B-B3F9-39D2C3E465DE}"/>
               </a:ext>
             </a:extLst>
           </p:cNvPr>
@@ -2190,7 +2190,7 @@
           <p:cNvPr id="4" name="problem-grid-value">
             <a:extLst xmlns:a="http://schemas.openxmlformats.org/drawingml/2006/main">
               <a:ext uri="{FF2B5EF4-FFF2-40B4-BE49-F238E27FC236}">
-                <a16:creationId xmlns:a16="http://schemas.microsoft.com/office/drawing/2014/main" id="{159F1724-DE38-45A9-A336-A2B6DDA2FCE2}"/>
+                <a16:creationId xmlns:a16="http://schemas.microsoft.com/office/drawing/2014/main" id="{15AA24B8-6B42-4DBF-A227-46476906CAC0}"/>
               </a:ext>
             </a:extLst>
           </p:cNvPr>
@@ -2240,7 +2240,7 @@
           <p:cNvPr id="5" name="problem-grid-label">
             <a:extLst xmlns:a="http://schemas.openxmlformats.org/drawingml/2006/main">
               <a:ext uri="{FF2B5EF4-FFF2-40B4-BE49-F238E27FC236}">
-                <a16:creationId xmlns:a16="http://schemas.microsoft.com/office/drawing/2014/main" id="{15461834-2DD9-41ED-8E92-83C431945D2D}"/>
+                <a16:creationId xmlns:a16="http://schemas.microsoft.com/office/drawing/2014/main" id="{310BFF5E-08FF-4E00-B0CE-EDF6D662E9FB}"/>
               </a:ext>
             </a:extLst>
           </p:cNvPr>
@@ -2290,7 +2290,7 @@
           <p:cNvPr id="6" name="problem-ground-value">
             <a:extLst xmlns:a="http://schemas.openxmlformats.org/drawingml/2006/main">
               <a:ext uri="{FF2B5EF4-FFF2-40B4-BE49-F238E27FC236}">
-                <a16:creationId xmlns:a16="http://schemas.microsoft.com/office/drawing/2014/main" id="{84EA4E0D-842C-4B70-B2AE-92DA856B6BAC}"/>
+                <a16:creationId xmlns:a16="http://schemas.microsoft.com/office/drawing/2014/main" id="{B6ED2445-7F1E-424F-80B0-876C39ABE6D6}"/>
               </a:ext>
             </a:extLst>
           </p:cNvPr>
@@ -2340,7 +2340,7 @@
           <p:cNvPr id="7" name="problem-ground-label">
             <a:extLst xmlns:a="http://schemas.openxmlformats.org/drawingml/2006/main">
               <a:ext uri="{FF2B5EF4-FFF2-40B4-BE49-F238E27FC236}">
-                <a16:creationId xmlns:a16="http://schemas.microsoft.com/office/drawing/2014/main" id="{F46F58A3-9BE7-48C8-9438-E509F35E3E8E}"/>
+                <a16:creationId xmlns:a16="http://schemas.microsoft.com/office/drawing/2014/main" id="{122EF1CB-FBF7-4884-BEE4-E69A07EE9762}"/>
               </a:ext>
             </a:extLst>
           </p:cNvPr>
@@ -2390,7 +2390,7 @@
           <p:cNvPr id="8" name="problem-pilot-value">
             <a:extLst xmlns:a="http://schemas.openxmlformats.org/drawingml/2006/main">
               <a:ext uri="{FF2B5EF4-FFF2-40B4-BE49-F238E27FC236}">
-                <a16:creationId xmlns:a16="http://schemas.microsoft.com/office/drawing/2014/main" id="{0A797774-E217-401C-BDCC-EC875BD0C4A2}"/>
+                <a16:creationId xmlns:a16="http://schemas.microsoft.com/office/drawing/2014/main" id="{40A8F8CE-7F72-4BCF-B1DC-C4FCB1FFFDB0}"/>
               </a:ext>
             </a:extLst>
           </p:cNvPr>
@@ -2440,7 +2440,7 @@
           <p:cNvPr id="9" name="problem-pilot-label">
             <a:extLst xmlns:a="http://schemas.openxmlformats.org/drawingml/2006/main">
               <a:ext uri="{FF2B5EF4-FFF2-40B4-BE49-F238E27FC236}">
-                <a16:creationId xmlns:a16="http://schemas.microsoft.com/office/drawing/2014/main" id="{D831CDB5-9BE1-4096-920A-0BBF613A0430}"/>
+                <a16:creationId xmlns:a16="http://schemas.microsoft.com/office/drawing/2014/main" id="{F652983E-9FBA-48EB-9C98-C4B3A01F2439}"/>
               </a:ext>
             </a:extLst>
           </p:cNvPr>
@@ -2490,7 +2490,7 @@
           <p:cNvPr id="10" name="problem-takeaway">
             <a:extLst xmlns:a="http://schemas.openxmlformats.org/drawingml/2006/main">
               <a:ext uri="{FF2B5EF4-FFF2-40B4-BE49-F238E27FC236}">
-                <a16:creationId xmlns:a16="http://schemas.microsoft.com/office/drawing/2014/main" id="{7FBBFB01-6CED-453A-8B3C-01B704CC9BD6}"/>
+                <a16:creationId xmlns:a16="http://schemas.microsoft.com/office/drawing/2014/main" id="{A4A9EBA1-B0BF-4811-8302-1E45E86BF1D9}"/>
               </a:ext>
             </a:extLst>
           </p:cNvPr>
@@ -2540,7 +2540,7 @@
           <p:cNvPr id="11" name="problem-body">
             <a:extLst xmlns:a="http://schemas.openxmlformats.org/drawingml/2006/main">
               <a:ext uri="{FF2B5EF4-FFF2-40B4-BE49-F238E27FC236}">
-                <a16:creationId xmlns:a16="http://schemas.microsoft.com/office/drawing/2014/main" id="{7C5524F9-4057-438C-B957-E41006422B07}"/>
+                <a16:creationId xmlns:a16="http://schemas.microsoft.com/office/drawing/2014/main" id="{5DCEF084-309B-4C9E-9B1C-2777E5BFE342}"/>
               </a:ext>
             </a:extLst>
           </p:cNvPr>
@@ -2590,7 +2590,7 @@
           <p:cNvPr id="12" name="footer-brand-2">
             <a:extLst xmlns:a="http://schemas.openxmlformats.org/drawingml/2006/main">
               <a:ext uri="{FF2B5EF4-FFF2-40B4-BE49-F238E27FC236}">
-                <a16:creationId xmlns:a16="http://schemas.microsoft.com/office/drawing/2014/main" id="{97FB241A-B8F6-4EA8-847C-19C1A96BE50B}"/>
+                <a16:creationId xmlns:a16="http://schemas.microsoft.com/office/drawing/2014/main" id="{F87F3291-0580-4B86-A0D6-7C8FB6E12A48}"/>
               </a:ext>
             </a:extLst>
           </p:cNvPr>
@@ -2640,7 +2640,7 @@
           <p:cNvPr id="13" name="footer-index-2">
             <a:extLst xmlns:a="http://schemas.openxmlformats.org/drawingml/2006/main">
               <a:ext uri="{FF2B5EF4-FFF2-40B4-BE49-F238E27FC236}">
-                <a16:creationId xmlns:a16="http://schemas.microsoft.com/office/drawing/2014/main" id="{195288BA-6CD2-401F-BBA6-DB31069AB59E}"/>
+                <a16:creationId xmlns:a16="http://schemas.microsoft.com/office/drawing/2014/main" id="{2FF57966-86BF-4123-98AE-A37798DFECD8}"/>
               </a:ext>
             </a:extLst>
           </p:cNvPr>
@@ -2688,7 +2688,7 @@
     </p:spTree>
     <p:extLst>
       <p:ext uri="{BB962C8B-B14F-4D97-AF65-F5344CB8AC3E}">
-        <p14:creationId xmlns:p14="http://schemas.microsoft.com/office/powerpoint/2010/main" val="2016608003"/>
+        <p14:creationId xmlns:p14="http://schemas.microsoft.com/office/powerpoint/2010/main" val="66613105"/>
       </p:ext>
     </p:extLst>
   </p:cSld>
@@ -2719,7 +2719,7 @@
           <p:cNvPr id="9" name="evidence-kicker">
             <a:extLst xmlns:a="http://schemas.openxmlformats.org/drawingml/2006/main">
               <a:ext uri="{FF2B5EF4-FFF2-40B4-BE49-F238E27FC236}">
-                <a16:creationId xmlns:a16="http://schemas.microsoft.com/office/drawing/2014/main" id="{4E137E3C-1753-4E1B-ADF4-BE5D8FE69801}"/>
+                <a16:creationId xmlns:a16="http://schemas.microsoft.com/office/drawing/2014/main" id="{AE33C7E0-4F4C-431A-B5E1-3DC686C802CA}"/>
               </a:ext>
             </a:extLst>
           </p:cNvPr>
@@ -2769,7 +2769,7 @@
           <p:cNvPr id="2" name="evidence-title">
             <a:extLst xmlns:a="http://schemas.openxmlformats.org/drawingml/2006/main">
               <a:ext uri="{FF2B5EF4-FFF2-40B4-BE49-F238E27FC236}">
-                <a16:creationId xmlns:a16="http://schemas.microsoft.com/office/drawing/2014/main" id="{B34C4F00-65D0-4126-81F0-75C466DA762A}"/>
+                <a16:creationId xmlns:a16="http://schemas.microsoft.com/office/drawing/2014/main" id="{3137B77E-5602-4556-9E37-B793FC0D9ADA}"/>
               </a:ext>
             </a:extLst>
           </p:cNvPr>
@@ -2809,7 +2809,7 @@
                   <a:srgbClr val="18211E"/>
                 </a:solidFill>
               </a:rPr>
-              <a:t>Live context now includes modeled HCHO and NO₂.</a:t>
+              <a:t>A real Sentinel-5P layer anchors the live model context.</a:t>
             </a:r>
           </a:p>
         </p:txBody>
@@ -2819,7 +2819,7 @@
           <p:cNvPr id="3" name="evidence-values">
             <a:extLst xmlns:a="http://schemas.openxmlformats.org/drawingml/2006/main">
               <a:ext uri="{FF2B5EF4-FFF2-40B4-BE49-F238E27FC236}">
-                <a16:creationId xmlns:a16="http://schemas.microsoft.com/office/drawing/2014/main" id="{303C2ABD-5D41-4F63-882F-58C6390B7E5B}"/>
+                <a16:creationId xmlns:a16="http://schemas.microsoft.com/office/drawing/2014/main" id="{1E4B274F-F7D3-411C-A179-B65788497C14}"/>
               </a:ext>
             </a:extLst>
           </p:cNvPr>
@@ -2859,7 +2859,7 @@
                   <a:srgbClr val="347FAA"/>
                 </a:solidFill>
               </a:rPr>
-              <a:t>US AQI 50   ·   HCHO 1.3 µg/m³   ·   NO₂ 4.5 µg/m³   ·   08 Aug 2026, 22:30 IST</a:t>
+              <a:t>NASA GIBS NO₂ column · 08 Aug 2026   |   CAMS US AQI 47 · 09 Aug 2026</a:t>
             </a:r>
           </a:p>
         </p:txBody>
@@ -2869,7 +2869,7 @@
           <p:cNvPr id="4" name="evidence-frame">
             <a:extLst xmlns:a="http://schemas.openxmlformats.org/drawingml/2006/main">
               <a:ext uri="{FF2B5EF4-FFF2-40B4-BE49-F238E27FC236}">
-                <a16:creationId xmlns:a16="http://schemas.microsoft.com/office/drawing/2014/main" id="{98D48CBD-FC3D-470F-93C5-463617342A42}"/>
+                <a16:creationId xmlns:a16="http://schemas.microsoft.com/office/drawing/2014/main" id="{B0FD1928-AB83-43BC-AC5E-3F794195F370}"/>
               </a:ext>
             </a:extLst>
           </p:cNvPr>
@@ -2906,7 +2906,7 @@
           <p:nvPr/>
         </p:nvPicPr>
         <p:blipFill>
-          <a:blip xmlns:r="http://schemas.openxmlformats.org/officeDocument/2006/relationships" xmlns:a="http://schemas.openxmlformats.org/drawingml/2006/main" r:embed="R0f0bb31b50d74754"/>
+          <a:blip xmlns:r="http://schemas.openxmlformats.org/officeDocument/2006/relationships" xmlns:a="http://schemas.openxmlformats.org/drawingml/2006/main" r:embed="R95903942ef274606"/>
           <a:srcRect xmlns:a="http://schemas.openxmlformats.org/drawingml/2006/main" l="0" t="17050" r="0" b="17050"/>
           <a:stretch xmlns:a="http://schemas.openxmlformats.org/drawingml/2006/main">
             <a:fillRect l="0" t="0" r="0" b="0"/>
@@ -2927,7 +2927,7 @@
           <p:cNvPr id="6" name="evidence-caveat">
             <a:extLst xmlns:a="http://schemas.openxmlformats.org/drawingml/2006/main">
               <a:ext uri="{FF2B5EF4-FFF2-40B4-BE49-F238E27FC236}">
-                <a16:creationId xmlns:a16="http://schemas.microsoft.com/office/drawing/2014/main" id="{3996C32A-F8BB-465B-8DC5-E28074CD6339}"/>
+                <a16:creationId xmlns:a16="http://schemas.microsoft.com/office/drawing/2014/main" id="{3378594F-78AC-4DAE-A5BC-0529C00A6061}"/>
               </a:ext>
             </a:extLst>
           </p:cNvPr>
@@ -2939,7 +2939,7 @@
         <p:spPr>
           <a:xfrm xmlns:a="http://schemas.openxmlformats.org/drawingml/2006/main">
             <a:off x="533400" y="6153150"/>
-            <a:ext cx="9334500" cy="228600"/>
+            <a:ext cx="10287000" cy="228600"/>
           </a:xfrm>
           <a:prstGeom xmlns:a="http://schemas.openxmlformats.org/drawingml/2006/main" prst="rect">
             <a:avLst/>
@@ -2967,7 +2967,7 @@
                   <a:srgbClr val="E66B32"/>
                 </a:solidFill>
               </a:rPr>
-              <a:t>CAMS near-surface model · not Sentinel-5P column data · not a sensor reading</a:t>
+              <a:t>NASA GIBS = atmospheric column · CAMS numbers = near-surface model · neither is a sensor reading</a:t>
             </a:r>
           </a:p>
         </p:txBody>
@@ -2977,7 +2977,7 @@
           <p:cNvPr id="7" name="footer-brand-3">
             <a:extLst xmlns:a="http://schemas.openxmlformats.org/drawingml/2006/main">
               <a:ext uri="{FF2B5EF4-FFF2-40B4-BE49-F238E27FC236}">
-                <a16:creationId xmlns:a16="http://schemas.microsoft.com/office/drawing/2014/main" id="{1ED6E801-3C65-4385-A209-9660B78C28A0}"/>
+                <a16:creationId xmlns:a16="http://schemas.microsoft.com/office/drawing/2014/main" id="{B233B152-DF06-46CA-A493-439330CE0268}"/>
               </a:ext>
             </a:extLst>
           </p:cNvPr>
@@ -3027,7 +3027,7 @@
           <p:cNvPr id="8" name="footer-index-3">
             <a:extLst xmlns:a="http://schemas.openxmlformats.org/drawingml/2006/main">
               <a:ext uri="{FF2B5EF4-FFF2-40B4-BE49-F238E27FC236}">
-                <a16:creationId xmlns:a16="http://schemas.microsoft.com/office/drawing/2014/main" id="{28568F25-332B-459C-BE43-23315F24DE57}"/>
+                <a16:creationId xmlns:a16="http://schemas.microsoft.com/office/drawing/2014/main" id="{7F6E409D-B223-43AD-8AB5-31BE98DE1163}"/>
               </a:ext>
             </a:extLst>
           </p:cNvPr>
@@ -3075,7 +3075,7 @@
     </p:spTree>
     <p:extLst>
       <p:ext uri="{BB962C8B-B14F-4D97-AF65-F5344CB8AC3E}">
-        <p14:creationId xmlns:p14="http://schemas.microsoft.com/office/powerpoint/2010/main" val="1808203783"/>
+        <p14:creationId xmlns:p14="http://schemas.microsoft.com/office/powerpoint/2010/main" val="721397998"/>
       </p:ext>
     </p:extLst>
   </p:cSld>
@@ -3106,7 +3106,7 @@
           <p:cNvPr id="12" name="sensor-kicker">
             <a:extLst xmlns:a="http://schemas.openxmlformats.org/drawingml/2006/main">
               <a:ext uri="{FF2B5EF4-FFF2-40B4-BE49-F238E27FC236}">
-                <a16:creationId xmlns:a16="http://schemas.microsoft.com/office/drawing/2014/main" id="{DF8E1F5B-FE0E-4AEC-818E-F8772152616C}"/>
+                <a16:creationId xmlns:a16="http://schemas.microsoft.com/office/drawing/2014/main" id="{DB46F5AD-E299-4999-B82B-8148B029EF71}"/>
               </a:ext>
             </a:extLst>
           </p:cNvPr>
@@ -3156,7 +3156,7 @@
           <p:cNvPr id="2" name="sensor-title">
             <a:extLst xmlns:a="http://schemas.openxmlformats.org/drawingml/2006/main">
               <a:ext uri="{FF2B5EF4-FFF2-40B4-BE49-F238E27FC236}">
-                <a16:creationId xmlns:a16="http://schemas.microsoft.com/office/drawing/2014/main" id="{5FB425B2-17A1-46E8-BBE0-B3DA8E91D46C}"/>
+                <a16:creationId xmlns:a16="http://schemas.microsoft.com/office/drawing/2014/main" id="{8F3BAB39-CB2F-4967-A334-E937953573BE}"/>
               </a:ext>
             </a:extLst>
           </p:cNvPr>
@@ -3206,7 +3206,7 @@
           <p:cNvPr id="3" name="sensor-image-frame">
             <a:extLst xmlns:a="http://schemas.openxmlformats.org/drawingml/2006/main">
               <a:ext uri="{FF2B5EF4-FFF2-40B4-BE49-F238E27FC236}">
-                <a16:creationId xmlns:a16="http://schemas.microsoft.com/office/drawing/2014/main" id="{E3E0CA47-7AA9-42FC-810C-836323C0BFFD}"/>
+                <a16:creationId xmlns:a16="http://schemas.microsoft.com/office/drawing/2014/main" id="{43C4D605-8550-49FD-882F-A5B3C33B5E85}"/>
               </a:ext>
             </a:extLst>
           </p:cNvPr>
@@ -3243,7 +3243,7 @@
           <p:nvPr/>
         </p:nvPicPr>
         <p:blipFill>
-          <a:blip xmlns:r="http://schemas.openxmlformats.org/officeDocument/2006/relationships" xmlns:a="http://schemas.openxmlformats.org/drawingml/2006/main" r:embed="R0e89bf9f8e80449d"/>
+          <a:blip xmlns:r="http://schemas.openxmlformats.org/officeDocument/2006/relationships" xmlns:a="http://schemas.openxmlformats.org/drawingml/2006/main" r:embed="R950dd93f14c943c3"/>
           <a:srcRect xmlns:a="http://schemas.openxmlformats.org/drawingml/2006/main" l="4511" t="0" r="4511" b="0"/>
           <a:stretch xmlns:a="http://schemas.openxmlformats.org/drawingml/2006/main">
             <a:fillRect l="0" t="0" r="0" b="0"/>
@@ -3264,7 +3264,7 @@
           <p:cNvPr id="5" name="sensor-score">
             <a:extLst xmlns:a="http://schemas.openxmlformats.org/drawingml/2006/main">
               <a:ext uri="{FF2B5EF4-FFF2-40B4-BE49-F238E27FC236}">
-                <a16:creationId xmlns:a16="http://schemas.microsoft.com/office/drawing/2014/main" id="{C1F17B32-ADC7-4028-A44F-A4E9CF0E7B22}"/>
+                <a16:creationId xmlns:a16="http://schemas.microsoft.com/office/drawing/2014/main" id="{A58473F2-6C45-490A-AD0E-60D57507F3E0}"/>
               </a:ext>
             </a:extLst>
           </p:cNvPr>
@@ -3314,7 +3314,7 @@
           <p:cNvPr id="6" name="sensor-name">
             <a:extLst xmlns:a="http://schemas.openxmlformats.org/drawingml/2006/main">
               <a:ext uri="{FF2B5EF4-FFF2-40B4-BE49-F238E27FC236}">
-                <a16:creationId xmlns:a16="http://schemas.microsoft.com/office/drawing/2014/main" id="{B87D503A-6B2E-4C9D-A481-50E38A1C59CC}"/>
+                <a16:creationId xmlns:a16="http://schemas.microsoft.com/office/drawing/2014/main" id="{040D6CCF-6A4E-46A9-AD00-4C677EE6BA6D}"/>
               </a:ext>
             </a:extLst>
           </p:cNvPr>
@@ -3364,7 +3364,7 @@
           <p:cNvPr id="7" name="sensor-metrics">
             <a:extLst xmlns:a="http://schemas.openxmlformats.org/drawingml/2006/main">
               <a:ext uri="{FF2B5EF4-FFF2-40B4-BE49-F238E27FC236}">
-                <a16:creationId xmlns:a16="http://schemas.microsoft.com/office/drawing/2014/main" id="{FB9635D3-9401-45B1-97E2-D730F154ABE3}"/>
+                <a16:creationId xmlns:a16="http://schemas.microsoft.com/office/drawing/2014/main" id="{C8A550E9-6B62-4382-A7BC-15F4A65F4D52}"/>
               </a:ext>
             </a:extLst>
           </p:cNvPr>
@@ -3448,7 +3448,7 @@
           <p:cNvPr id="8" name="sensor-note-rule">
             <a:extLst xmlns:a="http://schemas.openxmlformats.org/drawingml/2006/main">
               <a:ext uri="{FF2B5EF4-FFF2-40B4-BE49-F238E27FC236}">
-                <a16:creationId xmlns:a16="http://schemas.microsoft.com/office/drawing/2014/main" id="{73FAD3C3-0CCE-4869-85DB-8270E2430CA0}"/>
+                <a16:creationId xmlns:a16="http://schemas.microsoft.com/office/drawing/2014/main" id="{D04B8F7B-1184-45D7-AFB3-179F1C2EFEA7}"/>
               </a:ext>
             </a:extLst>
           </p:cNvPr>
@@ -3479,7 +3479,7 @@
           <p:cNvPr id="9" name="sensor-note">
             <a:extLst xmlns:a="http://schemas.openxmlformats.org/drawingml/2006/main">
               <a:ext uri="{FF2B5EF4-FFF2-40B4-BE49-F238E27FC236}">
-                <a16:creationId xmlns:a16="http://schemas.microsoft.com/office/drawing/2014/main" id="{D94DBF79-11C2-4379-88A6-0510E5232AAE}"/>
+                <a16:creationId xmlns:a16="http://schemas.microsoft.com/office/drawing/2014/main" id="{4342EC4C-F265-4F8B-848E-705B3EB5870E}"/>
               </a:ext>
             </a:extLst>
           </p:cNvPr>
@@ -3529,7 +3529,7 @@
           <p:cNvPr id="10" name="footer-brand-4">
             <a:extLst xmlns:a="http://schemas.openxmlformats.org/drawingml/2006/main">
               <a:ext uri="{FF2B5EF4-FFF2-40B4-BE49-F238E27FC236}">
-                <a16:creationId xmlns:a16="http://schemas.microsoft.com/office/drawing/2014/main" id="{89F37039-321F-4AA9-854F-CBEC85DAFCCD}"/>
+                <a16:creationId xmlns:a16="http://schemas.microsoft.com/office/drawing/2014/main" id="{6ACF29DE-D60A-4320-BBF8-C6DD09A1F1BA}"/>
               </a:ext>
             </a:extLst>
           </p:cNvPr>
@@ -3579,7 +3579,7 @@
           <p:cNvPr id="11" name="footer-index-4">
             <a:extLst xmlns:a="http://schemas.openxmlformats.org/drawingml/2006/main">
               <a:ext uri="{FF2B5EF4-FFF2-40B4-BE49-F238E27FC236}">
-                <a16:creationId xmlns:a16="http://schemas.microsoft.com/office/drawing/2014/main" id="{42C34FEB-7AF0-4EBF-9740-4C92DC56C3AB}"/>
+                <a16:creationId xmlns:a16="http://schemas.microsoft.com/office/drawing/2014/main" id="{D06D48D7-FA2F-4D9C-89F5-16B619F140F5}"/>
               </a:ext>
             </a:extLst>
           </p:cNvPr>
@@ -3627,7 +3627,7 @@
     </p:spTree>
     <p:extLst>
       <p:ext uri="{BB962C8B-B14F-4D97-AF65-F5344CB8AC3E}">
-        <p14:creationId xmlns:p14="http://schemas.microsoft.com/office/powerpoint/2010/main" val="762124668"/>
+        <p14:creationId xmlns:p14="http://schemas.microsoft.com/office/powerpoint/2010/main" val="1951529145"/>
       </p:ext>
     </p:extLst>
   </p:cSld>
@@ -3658,7 +3658,7 @@
           <p:cNvPr id="13" name="pilot-kicker">
             <a:extLst xmlns:a="http://schemas.openxmlformats.org/drawingml/2006/main">
               <a:ext uri="{FF2B5EF4-FFF2-40B4-BE49-F238E27FC236}">
-                <a16:creationId xmlns:a16="http://schemas.microsoft.com/office/drawing/2014/main" id="{282E1867-E753-4AB5-8E22-7E3C8392442B}"/>
+                <a16:creationId xmlns:a16="http://schemas.microsoft.com/office/drawing/2014/main" id="{ED2784F3-7D07-4E7A-9F6E-CF01459A436D}"/>
               </a:ext>
             </a:extLst>
           </p:cNvPr>
@@ -3708,7 +3708,7 @@
           <p:cNvPr id="2" name="pilot-title">
             <a:extLst xmlns:a="http://schemas.openxmlformats.org/drawingml/2006/main">
               <a:ext uri="{FF2B5EF4-FFF2-40B4-BE49-F238E27FC236}">
-                <a16:creationId xmlns:a16="http://schemas.microsoft.com/office/drawing/2014/main" id="{6D0572CD-D616-4486-83F0-D9881BD8D303}"/>
+                <a16:creationId xmlns:a16="http://schemas.microsoft.com/office/drawing/2014/main" id="{83651022-AFE3-4C62-B348-FE0A9CE7D6CF}"/>
               </a:ext>
             </a:extLst>
           </p:cNvPr>
@@ -3758,7 +3758,7 @@
           <p:cNvPr id="3" name="pilot-image-frame">
             <a:extLst xmlns:a="http://schemas.openxmlformats.org/drawingml/2006/main">
               <a:ext uri="{FF2B5EF4-FFF2-40B4-BE49-F238E27FC236}">
-                <a16:creationId xmlns:a16="http://schemas.microsoft.com/office/drawing/2014/main" id="{1F2494BE-E120-4D93-8B88-1023E2075720}"/>
+                <a16:creationId xmlns:a16="http://schemas.microsoft.com/office/drawing/2014/main" id="{379C9B01-DE72-478B-B191-2A6DA89F3DCC}"/>
               </a:ext>
             </a:extLst>
           </p:cNvPr>
@@ -3795,7 +3795,7 @@
           <p:nvPr/>
         </p:nvPicPr>
         <p:blipFill>
-          <a:blip xmlns:r="http://schemas.openxmlformats.org/officeDocument/2006/relationships" xmlns:a="http://schemas.openxmlformats.org/drawingml/2006/main" r:embed="R1415411faf18466e"/>
+          <a:blip xmlns:r="http://schemas.openxmlformats.org/officeDocument/2006/relationships" xmlns:a="http://schemas.openxmlformats.org/drawingml/2006/main" r:embed="Rbd6762e4ebd24e87"/>
           <a:srcRect xmlns:a="http://schemas.openxmlformats.org/drawingml/2006/main" l="6929" t="0" r="6929" b="0"/>
           <a:stretch xmlns:a="http://schemas.openxmlformats.org/drawingml/2006/main">
             <a:fillRect l="0" t="0" r="0" b="0"/>
@@ -3816,7 +3816,7 @@
           <p:cNvPr id="5" name="pilot-time">
             <a:extLst xmlns:a="http://schemas.openxmlformats.org/drawingml/2006/main">
               <a:ext uri="{FF2B5EF4-FFF2-40B4-BE49-F238E27FC236}">
-                <a16:creationId xmlns:a16="http://schemas.microsoft.com/office/drawing/2014/main" id="{0F70D02A-067D-4C00-900F-E2A73D0088AF}"/>
+                <a16:creationId xmlns:a16="http://schemas.microsoft.com/office/drawing/2014/main" id="{61651269-5967-48BD-BFDC-7A031DB4FDDC}"/>
               </a:ext>
             </a:extLst>
           </p:cNvPr>
@@ -3866,7 +3866,7 @@
           <p:cNvPr id="6" name="pilot-time-label">
             <a:extLst xmlns:a="http://schemas.openxmlformats.org/drawingml/2006/main">
               <a:ext uri="{FF2B5EF4-FFF2-40B4-BE49-F238E27FC236}">
-                <a16:creationId xmlns:a16="http://schemas.microsoft.com/office/drawing/2014/main" id="{2FC880E1-BBAA-4A72-BCAD-B17174F20374}"/>
+                <a16:creationId xmlns:a16="http://schemas.microsoft.com/office/drawing/2014/main" id="{B0868511-D6B2-4023-AAA1-1F0D0FCE9186}"/>
               </a:ext>
             </a:extLst>
           </p:cNvPr>
@@ -3916,7 +3916,7 @@
           <p:cNvPr id="7" name="pilot-cost">
             <a:extLst xmlns:a="http://schemas.openxmlformats.org/drawingml/2006/main">
               <a:ext uri="{FF2B5EF4-FFF2-40B4-BE49-F238E27FC236}">
-                <a16:creationId xmlns:a16="http://schemas.microsoft.com/office/drawing/2014/main" id="{E969970E-F3CF-426B-8124-407AA43C32DF}"/>
+                <a16:creationId xmlns:a16="http://schemas.microsoft.com/office/drawing/2014/main" id="{85753C49-C743-4FBD-AC79-22F9F97EAB79}"/>
               </a:ext>
             </a:extLst>
           </p:cNvPr>
@@ -3966,7 +3966,7 @@
           <p:cNvPr id="8" name="pilot-cost-label">
             <a:extLst xmlns:a="http://schemas.openxmlformats.org/drawingml/2006/main">
               <a:ext uri="{FF2B5EF4-FFF2-40B4-BE49-F238E27FC236}">
-                <a16:creationId xmlns:a16="http://schemas.microsoft.com/office/drawing/2014/main" id="{1D48E458-6432-4250-8412-2116030701E2}"/>
+                <a16:creationId xmlns:a16="http://schemas.microsoft.com/office/drawing/2014/main" id="{80E50BC3-3035-4988-91D4-3623AC0899C8}"/>
               </a:ext>
             </a:extLst>
           </p:cNvPr>
@@ -4016,7 +4016,7 @@
           <p:cNvPr id="9" name="pilot-steps">
             <a:extLst xmlns:a="http://schemas.openxmlformats.org/drawingml/2006/main">
               <a:ext uri="{FF2B5EF4-FFF2-40B4-BE49-F238E27FC236}">
-                <a16:creationId xmlns:a16="http://schemas.microsoft.com/office/drawing/2014/main" id="{9E3FD20D-0E84-4F86-8441-30184EC8584D}"/>
+                <a16:creationId xmlns:a16="http://schemas.microsoft.com/office/drawing/2014/main" id="{2F5389CC-26FC-4ADE-932E-BEE88BEE2FA3}"/>
               </a:ext>
             </a:extLst>
           </p:cNvPr>
@@ -4066,7 +4066,7 @@
           <p:cNvPr id="10" name="pilot-caveat">
             <a:extLst xmlns:a="http://schemas.openxmlformats.org/drawingml/2006/main">
               <a:ext uri="{FF2B5EF4-FFF2-40B4-BE49-F238E27FC236}">
-                <a16:creationId xmlns:a16="http://schemas.microsoft.com/office/drawing/2014/main" id="{AEB1F8D5-293D-4F22-BEE4-320914D6F4FF}"/>
+                <a16:creationId xmlns:a16="http://schemas.microsoft.com/office/drawing/2014/main" id="{E556C18C-AA03-47DB-9916-BB4750DF9CFE}"/>
               </a:ext>
             </a:extLst>
           </p:cNvPr>
@@ -4116,7 +4116,7 @@
           <p:cNvPr id="11" name="footer-brand-5">
             <a:extLst xmlns:a="http://schemas.openxmlformats.org/drawingml/2006/main">
               <a:ext uri="{FF2B5EF4-FFF2-40B4-BE49-F238E27FC236}">
-                <a16:creationId xmlns:a16="http://schemas.microsoft.com/office/drawing/2014/main" id="{2076DE4C-2674-43C7-85BC-6232EA33488E}"/>
+                <a16:creationId xmlns:a16="http://schemas.microsoft.com/office/drawing/2014/main" id="{0AC00C8A-87C1-4D5A-A7C0-1EECE165A409}"/>
               </a:ext>
             </a:extLst>
           </p:cNvPr>
@@ -4166,7 +4166,7 @@
           <p:cNvPr id="12" name="footer-index-5">
             <a:extLst xmlns:a="http://schemas.openxmlformats.org/drawingml/2006/main">
               <a:ext uri="{FF2B5EF4-FFF2-40B4-BE49-F238E27FC236}">
-                <a16:creationId xmlns:a16="http://schemas.microsoft.com/office/drawing/2014/main" id="{7A1EFDEC-3B32-4B75-9EB8-0370926E1FE7}"/>
+                <a16:creationId xmlns:a16="http://schemas.microsoft.com/office/drawing/2014/main" id="{5F54BF70-8F18-4E1B-BC02-5D200959367C}"/>
               </a:ext>
             </a:extLst>
           </p:cNvPr>
@@ -4214,7 +4214,7 @@
     </p:spTree>
     <p:extLst>
       <p:ext uri="{BB962C8B-B14F-4D97-AF65-F5344CB8AC3E}">
-        <p14:creationId xmlns:p14="http://schemas.microsoft.com/office/powerpoint/2010/main" val="1637568589"/>
+        <p14:creationId xmlns:p14="http://schemas.microsoft.com/office/powerpoint/2010/main" val="1920531288"/>
       </p:ext>
     </p:extLst>
   </p:cSld>
@@ -4245,7 +4245,7 @@
           <p:cNvPr id="14" name="ask-kicker">
             <a:extLst xmlns:a="http://schemas.openxmlformats.org/drawingml/2006/main">
               <a:ext uri="{FF2B5EF4-FFF2-40B4-BE49-F238E27FC236}">
-                <a16:creationId xmlns:a16="http://schemas.microsoft.com/office/drawing/2014/main" id="{157C37E7-6A55-4A54-BDA4-BDDA694AB276}"/>
+                <a16:creationId xmlns:a16="http://schemas.microsoft.com/office/drawing/2014/main" id="{0E302C46-A1DA-4AEF-8EB5-BC26B362F0A8}"/>
               </a:ext>
             </a:extLst>
           </p:cNvPr>
@@ -4295,7 +4295,7 @@
           <p:cNvPr id="2" name="ask-title">
             <a:extLst xmlns:a="http://schemas.openxmlformats.org/drawingml/2006/main">
               <a:ext uri="{FF2B5EF4-FFF2-40B4-BE49-F238E27FC236}">
-                <a16:creationId xmlns:a16="http://schemas.microsoft.com/office/drawing/2014/main" id="{BDB92AC2-33AF-4589-A119-BF5F4DAEBDD6}"/>
+                <a16:creationId xmlns:a16="http://schemas.microsoft.com/office/drawing/2014/main" id="{FD0FFF9C-9C08-421B-9034-158A359C139D}"/>
               </a:ext>
             </a:extLst>
           </p:cNvPr>
@@ -4362,7 +4362,7 @@
           <p:cNvPr id="3" name="ask-rule">
             <a:extLst xmlns:a="http://schemas.openxmlformats.org/drawingml/2006/main">
               <a:ext uri="{FF2B5EF4-FFF2-40B4-BE49-F238E27FC236}">
-                <a16:creationId xmlns:a16="http://schemas.microsoft.com/office/drawing/2014/main" id="{75C6D1A2-81B6-4618-9EB7-2603824920F0}"/>
+                <a16:creationId xmlns:a16="http://schemas.microsoft.com/office/drawing/2014/main" id="{C2EE5984-467B-46A3-8438-F7DBAEC5F020}"/>
               </a:ext>
             </a:extLst>
           </p:cNvPr>
@@ -4393,7 +4393,7 @@
           <p:cNvPr id="4" name="ask-1-num">
             <a:extLst xmlns:a="http://schemas.openxmlformats.org/drawingml/2006/main">
               <a:ext uri="{FF2B5EF4-FFF2-40B4-BE49-F238E27FC236}">
-                <a16:creationId xmlns:a16="http://schemas.microsoft.com/office/drawing/2014/main" id="{02403DF8-DAEF-4DD2-91F9-380C6E01BE1C}"/>
+                <a16:creationId xmlns:a16="http://schemas.microsoft.com/office/drawing/2014/main" id="{00637A25-B2F4-47F4-BDD1-A899809DA77B}"/>
               </a:ext>
             </a:extLst>
           </p:cNvPr>
@@ -4443,7 +4443,7 @@
           <p:cNvPr id="5" name="ask-1">
             <a:extLst xmlns:a="http://schemas.openxmlformats.org/drawingml/2006/main">
               <a:ext uri="{FF2B5EF4-FFF2-40B4-BE49-F238E27FC236}">
-                <a16:creationId xmlns:a16="http://schemas.microsoft.com/office/drawing/2014/main" id="{59B6C92F-B878-4BC4-AFD4-E31BFB83A5AD}"/>
+                <a16:creationId xmlns:a16="http://schemas.microsoft.com/office/drawing/2014/main" id="{81A7A981-7845-4B00-85F3-0A7C731F1B6C}"/>
               </a:ext>
             </a:extLst>
           </p:cNvPr>
@@ -4493,7 +4493,7 @@
           <p:cNvPr id="6" name="ask-2-num">
             <a:extLst xmlns:a="http://schemas.openxmlformats.org/drawingml/2006/main">
               <a:ext uri="{FF2B5EF4-FFF2-40B4-BE49-F238E27FC236}">
-                <a16:creationId xmlns:a16="http://schemas.microsoft.com/office/drawing/2014/main" id="{003CBB40-2D61-4AA3-A575-950CF849C7FE}"/>
+                <a16:creationId xmlns:a16="http://schemas.microsoft.com/office/drawing/2014/main" id="{DC3D7E3D-26D1-4505-840E-EF60ECC222AC}"/>
               </a:ext>
             </a:extLst>
           </p:cNvPr>
@@ -4543,7 +4543,7 @@
           <p:cNvPr id="7" name="ask-2">
             <a:extLst xmlns:a="http://schemas.openxmlformats.org/drawingml/2006/main">
               <a:ext uri="{FF2B5EF4-FFF2-40B4-BE49-F238E27FC236}">
-                <a16:creationId xmlns:a16="http://schemas.microsoft.com/office/drawing/2014/main" id="{136B7E0A-F000-4431-B755-2A06B5814CAB}"/>
+                <a16:creationId xmlns:a16="http://schemas.microsoft.com/office/drawing/2014/main" id="{880F90C7-4CE0-484A-9B34-7E8A92F8A02B}"/>
               </a:ext>
             </a:extLst>
           </p:cNvPr>
@@ -4593,7 +4593,7 @@
           <p:cNvPr id="8" name="ask-3-num">
             <a:extLst xmlns:a="http://schemas.openxmlformats.org/drawingml/2006/main">
               <a:ext uri="{FF2B5EF4-FFF2-40B4-BE49-F238E27FC236}">
-                <a16:creationId xmlns:a16="http://schemas.microsoft.com/office/drawing/2014/main" id="{401E3937-9A62-496E-8E92-7562EAD0B32C}"/>
+                <a16:creationId xmlns:a16="http://schemas.microsoft.com/office/drawing/2014/main" id="{4063BA00-95DC-4558-B78A-84BDA40ED314}"/>
               </a:ext>
             </a:extLst>
           </p:cNvPr>
@@ -4643,7 +4643,7 @@
           <p:cNvPr id="9" name="ask-3">
             <a:extLst xmlns:a="http://schemas.openxmlformats.org/drawingml/2006/main">
               <a:ext uri="{FF2B5EF4-FFF2-40B4-BE49-F238E27FC236}">
-                <a16:creationId xmlns:a16="http://schemas.microsoft.com/office/drawing/2014/main" id="{43542E6C-EC50-4621-AC89-E9965B5C6E41}"/>
+                <a16:creationId xmlns:a16="http://schemas.microsoft.com/office/drawing/2014/main" id="{3EAFC853-295E-4538-A37A-42930D971F4A}"/>
               </a:ext>
             </a:extLst>
           </p:cNvPr>
@@ -4693,7 +4693,7 @@
           <p:cNvPr id="10" name="ask-team">
             <a:extLst xmlns:a="http://schemas.openxmlformats.org/drawingml/2006/main">
               <a:ext uri="{FF2B5EF4-FFF2-40B4-BE49-F238E27FC236}">
-                <a16:creationId xmlns:a16="http://schemas.microsoft.com/office/drawing/2014/main" id="{F46076FF-440F-4374-8FCA-59457355C392}"/>
+                <a16:creationId xmlns:a16="http://schemas.microsoft.com/office/drawing/2014/main" id="{3635114D-5463-4729-ADB6-C0C4AAFE105C}"/>
               </a:ext>
             </a:extLst>
           </p:cNvPr>
@@ -4743,7 +4743,7 @@
           <p:cNvPr id="11" name="ask-link">
             <a:extLst xmlns:a="http://schemas.openxmlformats.org/drawingml/2006/main">
               <a:ext uri="{FF2B5EF4-FFF2-40B4-BE49-F238E27FC236}">
-                <a16:creationId xmlns:a16="http://schemas.microsoft.com/office/drawing/2014/main" id="{B3D6310A-22BD-4E7C-9F6E-FE538235EE99}"/>
+                <a16:creationId xmlns:a16="http://schemas.microsoft.com/office/drawing/2014/main" id="{23424C06-03A6-4386-B92E-F2EE33922F54}"/>
               </a:ext>
             </a:extLst>
           </p:cNvPr>
@@ -4793,7 +4793,7 @@
           <p:cNvPr id="12" name="footer-brand-6">
             <a:extLst xmlns:a="http://schemas.openxmlformats.org/drawingml/2006/main">
               <a:ext uri="{FF2B5EF4-FFF2-40B4-BE49-F238E27FC236}">
-                <a16:creationId xmlns:a16="http://schemas.microsoft.com/office/drawing/2014/main" id="{09690327-2EE7-4F84-B2F8-58A92C815089}"/>
+                <a16:creationId xmlns:a16="http://schemas.microsoft.com/office/drawing/2014/main" id="{5AC3B308-2B3C-43AD-8D2D-A37399C79C0A}"/>
               </a:ext>
             </a:extLst>
           </p:cNvPr>
@@ -4843,7 +4843,7 @@
           <p:cNvPr id="13" name="footer-index-6">
             <a:extLst xmlns:a="http://schemas.openxmlformats.org/drawingml/2006/main">
               <a:ext uri="{FF2B5EF4-FFF2-40B4-BE49-F238E27FC236}">
-                <a16:creationId xmlns:a16="http://schemas.microsoft.com/office/drawing/2014/main" id="{9B4F363B-AD3D-4F2B-8247-443DBBF85743}"/>
+                <a16:creationId xmlns:a16="http://schemas.microsoft.com/office/drawing/2014/main" id="{18C9F8A1-45F5-400E-A1E7-6483E4A14BB7}"/>
               </a:ext>
             </a:extLst>
           </p:cNvPr>
@@ -4891,7 +4891,7 @@
     </p:spTree>
     <p:extLst>
       <p:ext uri="{BB962C8B-B14F-4D97-AF65-F5344CB8AC3E}">
-        <p14:creationId xmlns:p14="http://schemas.microsoft.com/office/powerpoint/2010/main" val="437630125"/>
+        <p14:creationId xmlns:p14="http://schemas.microsoft.com/office/powerpoint/2010/main" val="1350191788"/>
       </p:ext>
     </p:extLst>
   </p:cSld>

</xml_diff>